<commit_message>
docs: rename to Multimodal Biology and add the DNA modality
- Rename the team skills from rna-fusion-* to multimodal-bio-* and update links
- README, docs, and research context: Multimodal Biology title, DNA-pretrained
  nucleotide encoder labeling, planned DNA/RNA/protein multi-encoder extension,
  stability dataset audit, Overleaf project links, new retained sources
- Notebooks: Markdown-only modality notes (no code or outputs changed)
- Shared project notes: DNA scope, Stage 1 extension steps, numbers synced to
  the current Stage1_refactor.ipynb outputs
- Julian's reviews: relevance sections updated for DNA, RNA, and protein
- Bibliography, Research Canvas, and Gantt: DNA-scope revision

Co-Authored-By: Claude Opus 5.5 <noreply@anthropic.com>
Claude-Session: https://claude.ai/code/session_01EXPvTz3oCycFbJjDeAyu2R
</commit_message>
<xml_diff>
--- a/docs/Research_Canvas.pptx
+++ b/docs/Research_Canvas.pptx
@@ -4453,7 +4453,7 @@
                           <a:ea typeface="Calibri"/>
                           <a:cs typeface="Calibri"/>
                         </a:rPr>
-                        <a:t>We begin with nucleotide and translated-protein representations for an mRNA stability case study. Frozen encoders let us investigate reusable features without retraining the foundation models.</a:t>
+                        <a:t>We begin with DNA-pretrained nucleotide and translated-protein representations for an mRNA stability case study, then extend to DNA, RNA and protein encoders with more than one model per modality. Frozen encoders let us investigate reusable features without retraining the foundation models.</a:t>
                       </a:r>
                     </a:p>
                     <a:p>
@@ -4613,7 +4613,7 @@
                           <a:ea typeface="Calibri"/>
                           <a:cs typeface="Calibri"/>
                         </a:rPr>
-                        <a:t>RQ4: Can combining RNA models improve prediction over the strongest individual RNA model?</a:t>
+                        <a:t>RQ4: Can combining several DNA, RNA or protein models improve prediction over the strongest individual model?</a:t>
                       </a:r>
                     </a:p>
                     <a:p>
@@ -4815,7 +4815,7 @@
                           <a:ea typeface="Calibri"/>
                           <a:cs typeface="Calibri"/>
                         </a:rPr>
-                        <a:t>October 5 review: explain the pipeline and findings, refine a working definition of alignment, and agree on the next experiments.</a:t>
+                        <a:t>October 5 review: explain the pipeline and findings, refine a working definition of alignment, and agree on DNA, RNA and protein comparisons with BioLangFusion and IsoFormer data.</a:t>
                       </a:r>
                     </a:p>
                   </a:txBody>
@@ -5506,7 +5506,7 @@
                           <a:ea typeface="Calibri"/>
                           <a:cs typeface="Calibri"/>
                         </a:rPr>
-                        <a:t>Frozen NT 500M (DNA-pretrained) and ESM-2 35M (translated protein): layer probes and PCA; later compare RNA encoders and tokenization.</a:t>
+                        <a:t>Frozen NT 500M (DNA-pretrained) and ESM-2 35M (translated protein): layer probes and PCA; then add RNA and further DNA and protein encoders.</a:t>
                       </a:r>
                     </a:p>
                     <a:p>
@@ -5527,7 +5527,7 @@
                           <a:ea typeface="Calibri"/>
                           <a:cs typeface="Calibri"/>
                         </a:rPr>
-                        <a:t>Adapt BioLangFusion; compare single models, concatenation + MLP, Coupled Mamba and cross-attention under matched evaluation.</a:t>
+                        <a:t>Adapt BioLangFusion and IsoFormer on their datasets; compare single models, concatenation + MLP, Coupled Mamba and cross-attention under matched evaluation.</a:t>
                       </a:r>
                     </a:p>
                     <a:p>
@@ -5628,7 +5628,7 @@
                           <a:ea typeface="Calibri"/>
                           <a:cs typeface="Calibri"/>
                         </a:rPr>
-                        <a:t>Choosing and Fusing Biological Foundation Models | Team research canvas | UCF CAP 6942</a:t>
+                        <a:t>Multimodal Biology: Choosing and Fusing Biological Foundation Models | Team research canvas | UCF CAP 6942</a:t>
                       </a:r>
                     </a:p>
                     <a:p>
@@ -5670,7 +5670,7 @@
                           <a:ea typeface="Calibri"/>
                           <a:cs typeface="Calibri"/>
                         </a:rPr>
-                        <a:t>AI assistance: OpenAI Codex assisted with wording and layout; source checks used project records, course materials and cited papers.</a:t>
+                        <a:t>AI assistance: OpenAI Codex assisted with wording and layout; Claude assisted with the DNA-scope revision; source checks used project records, course materials and cited papers.</a:t>
                       </a:r>
                     </a:p>
                   </a:txBody>

</xml_diff>

<commit_message>
Complete Stage 1 with twelve encoders and GTEx, and record the Stage 2 decision
Stage1_analysis.ipynb now runs twelve frozen encoders, four per modality,
on the mRNA stability pilot and on a GTEx pilot built by
Code/build_gtex_pilot.py, with result notes and interpretations after
every output. The run adds PCA variance bands, attention permutation
nulls, and published-split comparisons with BioLangFusion and IsoFormer.

The README, docs, project notes, October 7 slides, research canvas, and
Gantt plan describe the current results and the Stage 2 alignment
decision, which lives in the notes and the Overleaf project.

Co-Authored-By: Claude Opus 5.5 <noreply@anthropic.com>
Claude-Session: https://claude.ai/code/session_016z8BM931pKqvCtYb6578dV
</commit_message>
<xml_diff>
--- a/docs/Research_Canvas.pptx
+++ b/docs/Research_Canvas.pptx
@@ -4453,7 +4453,7 @@
                           <a:ea typeface="Calibri"/>
                           <a:cs typeface="Calibri"/>
                         </a:rPr>
-                        <a:t>We begin with DNA-pretrained nucleotide and translated-protein representations for an mRNA stability case study, then extend to DNA, RNA and protein encoders with more than one model per modality. Frozen encoders let us investigate reusable features without retraining the foundation models.</a:t>
+                        <a:t>We compare twelve frozen DNA, RNA and protein encoders, four per modality, on mRNA stability, where every input derives from one coding sequence, and on GTEx transcript expression, where DNA, transcript and protein are distinct inputs. Frozen encoders let us investigate reusable features without retraining the foundation models.</a:t>
                       </a:r>
                     </a:p>
                     <a:p>
@@ -4773,7 +4773,7 @@
                           <a:ea typeface="Calibri"/>
                           <a:cs typeface="Calibri"/>
                         </a:rPr>
-                        <a:t>Stage 1 notebooks contain predictive probes, representation comparisons and a synonymous-sequence control. Biological interpretation and reproducibility checks are in progress.</a:t>
+                        <a:t>Stage 1 is complete in one notebook: probes, geometry, a composition control, attention nulls and published-split comparisons for twelve encoders on two datasets.</a:t>
                       </a:r>
                     </a:p>
                     <a:p>
@@ -4794,7 +4794,7 @@
                           <a:ea typeface="Calibri"/>
                           <a:cs typeface="Calibri"/>
                         </a:rPr>
-                        <a:t>Producing runs and evaluation assumptions remain under review; numerical findings are not yet finalized. Stage 1 manuscript writing has begun in Overleaf.</a:t>
+                        <a:t>Codon-level RNA and protein encoders predict stability best (R² 0.11 to 0.14), and most agreement involving DNA encoders is composition. On GTEx, RNA and protein encoders lead, and transcript lengths alone match all encoders combined (R² 0.24).</a:t>
                       </a:r>
                     </a:p>
                     <a:p>
@@ -4815,7 +4815,7 @@
                           <a:ea typeface="Calibri"/>
                           <a:cs typeface="Calibri"/>
                         </a:rPr>
-                        <a:t>October 5 review: explain the pipeline and findings, refine a working definition of alignment, and agree on DNA, RNA and protein comparisons with BioLangFusion and IsoFormer data.</a:t>
+                        <a:t>October 7 review: present Stage 1 and the proposed Stage 2 alignment decision, then agree on the first Stage 3 fusion comparison.</a:t>
                       </a:r>
                     </a:p>
                   </a:txBody>
@@ -5506,7 +5506,7 @@
                           <a:ea typeface="Calibri"/>
                           <a:cs typeface="Calibri"/>
                         </a:rPr>
-                        <a:t>Frozen NT 500M (DNA-pretrained) and ESM-2 35M (translated protein): layer probes and PCA; then add RNA and further DNA and protein encoders.</a:t>
+                        <a:t>Twelve frozen encoders, four per modality: linear probes, layer-wise CKA, PCA bands, CCA retrieval and a composition control on stability and GTEx data.</a:t>
                       </a:r>
                     </a:p>
                     <a:p>
@@ -5670,7 +5670,7 @@
                           <a:ea typeface="Calibri"/>
                           <a:cs typeface="Calibri"/>
                         </a:rPr>
-                        <a:t>AI assistance: OpenAI Codex assisted with wording and layout; Claude assisted with the DNA-scope revision; source checks used project records, course materials and cited papers.</a:t>
+                        <a:t>AI assistance: OpenAI Codex assisted with wording and layout; Claude assisted with the DNA-scope revision and the October 3 status update; source checks used project records, course materials and cited papers.</a:t>
                       </a:r>
                     </a:p>
                   </a:txBody>

</xml_diff>